<commit_message>
Add triplex view, cycle counters, time-travel, photo uploads, and timezone labels
- Triplex overview showing 3 pump heads with suction/discharge flow lines
- Click-through navigation from triplex to detailed component diagram
- Cycle count and runtime stats displayed on diagram component cards
- Bulk /usage endpoint to avoid N+1 API calls for diagram display
- Time-travel date picker to view past configurations (read-only mode)
- Photo upload system with before/after/inspection tagging
- Auto-resize uploads to 1920px max via Pillow, HEIC support
- Photo gallery with lightbox viewer in part detail panel
- Local timezone labels on change form and history table
- Fixed motor speed query type mismatch with pg8000
- Widened side panel for better change history visibility

Co-Authored-By: Claude Opus 4.6 <noreply@anthropic.com>
</commit_message>
<xml_diff>
--- a/asset_model_diagram.pptx
+++ b/asset_model_diagram.pptx
@@ -104,6 +104,11 @@
       </a:defRPr>
     </a:lvl9pPr>
   </p:defaultTextStyle>
+  <p:extLst>
+    <p:ext uri="{EFAFB233-063F-42B5-8137-9DF3F51BA10A}">
+      <p15:sldGuideLst xmlns:p15="http://schemas.microsoft.com/office/powerpoint/2012/main"/>
+    </p:ext>
+  </p:extLst>
 </p:presentation>
 </file>
 
@@ -254,7 +259,7 @@
           <a:p>
             <a:fld id="{FC83124A-49AE-4925-9D3F-7822D9936C61}" type="datetimeFigureOut">
               <a:rPr lang="en-US" smtClean="0"/>
-              <a:t>6/4/2026</a:t>
+              <a:t>7/6/2026</a:t>
             </a:fld>
             <a:endParaRPr lang="en-US"/>
           </a:p>
@@ -452,7 +457,7 @@
           <a:p>
             <a:fld id="{FC83124A-49AE-4925-9D3F-7822D9936C61}" type="datetimeFigureOut">
               <a:rPr lang="en-US" smtClean="0"/>
-              <a:t>6/4/2026</a:t>
+              <a:t>7/6/2026</a:t>
             </a:fld>
             <a:endParaRPr lang="en-US"/>
           </a:p>
@@ -660,7 +665,7 @@
           <a:p>
             <a:fld id="{FC83124A-49AE-4925-9D3F-7822D9936C61}" type="datetimeFigureOut">
               <a:rPr lang="en-US" smtClean="0"/>
-              <a:t>6/4/2026</a:t>
+              <a:t>7/6/2026</a:t>
             </a:fld>
             <a:endParaRPr lang="en-US"/>
           </a:p>
@@ -858,7 +863,7 @@
           <a:p>
             <a:fld id="{FC83124A-49AE-4925-9D3F-7822D9936C61}" type="datetimeFigureOut">
               <a:rPr lang="en-US" smtClean="0"/>
-              <a:t>6/4/2026</a:t>
+              <a:t>7/6/2026</a:t>
             </a:fld>
             <a:endParaRPr lang="en-US"/>
           </a:p>
@@ -1133,7 +1138,7 @@
           <a:p>
             <a:fld id="{FC83124A-49AE-4925-9D3F-7822D9936C61}" type="datetimeFigureOut">
               <a:rPr lang="en-US" smtClean="0"/>
-              <a:t>6/4/2026</a:t>
+              <a:t>7/6/2026</a:t>
             </a:fld>
             <a:endParaRPr lang="en-US"/>
           </a:p>
@@ -1398,7 +1403,7 @@
           <a:p>
             <a:fld id="{FC83124A-49AE-4925-9D3F-7822D9936C61}" type="datetimeFigureOut">
               <a:rPr lang="en-US" smtClean="0"/>
-              <a:t>6/4/2026</a:t>
+              <a:t>7/6/2026</a:t>
             </a:fld>
             <a:endParaRPr lang="en-US"/>
           </a:p>
@@ -1810,7 +1815,7 @@
           <a:p>
             <a:fld id="{FC83124A-49AE-4925-9D3F-7822D9936C61}" type="datetimeFigureOut">
               <a:rPr lang="en-US" smtClean="0"/>
-              <a:t>6/4/2026</a:t>
+              <a:t>7/6/2026</a:t>
             </a:fld>
             <a:endParaRPr lang="en-US"/>
           </a:p>
@@ -1951,7 +1956,7 @@
           <a:p>
             <a:fld id="{FC83124A-49AE-4925-9D3F-7822D9936C61}" type="datetimeFigureOut">
               <a:rPr lang="en-US" smtClean="0"/>
-              <a:t>6/4/2026</a:t>
+              <a:t>7/6/2026</a:t>
             </a:fld>
             <a:endParaRPr lang="en-US"/>
           </a:p>
@@ -2064,7 +2069,7 @@
           <a:p>
             <a:fld id="{FC83124A-49AE-4925-9D3F-7822D9936C61}" type="datetimeFigureOut">
               <a:rPr lang="en-US" smtClean="0"/>
-              <a:t>6/4/2026</a:t>
+              <a:t>7/6/2026</a:t>
             </a:fld>
             <a:endParaRPr lang="en-US"/>
           </a:p>
@@ -2375,7 +2380,7 @@
           <a:p>
             <a:fld id="{FC83124A-49AE-4925-9D3F-7822D9936C61}" type="datetimeFigureOut">
               <a:rPr lang="en-US" smtClean="0"/>
-              <a:t>6/4/2026</a:t>
+              <a:t>7/6/2026</a:t>
             </a:fld>
             <a:endParaRPr lang="en-US"/>
           </a:p>
@@ -2663,7 +2668,7 @@
           <a:p>
             <a:fld id="{FC83124A-49AE-4925-9D3F-7822D9936C61}" type="datetimeFigureOut">
               <a:rPr lang="en-US" smtClean="0"/>
-              <a:t>6/4/2026</a:t>
+              <a:t>7/6/2026</a:t>
             </a:fld>
             <a:endParaRPr lang="en-US"/>
           </a:p>
@@ -2904,7 +2909,7 @@
           <a:p>
             <a:fld id="{FC83124A-49AE-4925-9D3F-7822D9936C61}" type="datetimeFigureOut">
               <a:rPr lang="en-US" smtClean="0"/>
-              <a:t>6/4/2026</a:t>
+              <a:t>7/6/2026</a:t>
             </a:fld>
             <a:endParaRPr lang="en-US"/>
           </a:p>
@@ -3335,8 +3340,8 @@
         </p:nvSpPr>
         <p:spPr>
           <a:xfrm>
-            <a:off x="1453896" y="1316736"/>
-            <a:ext cx="7644384" cy="3483864"/>
+            <a:off x="1453896" y="2309876"/>
+            <a:ext cx="9180576" cy="3730752"/>
           </a:xfrm>
           <a:prstGeom prst="rect">
             <a:avLst/>
@@ -3365,7 +3370,6 @@
           <a:bodyPr rtlCol="0" anchor="t"/>
           <a:lstStyle/>
           <a:p>
-            <a:pPr algn="ctr"/>
             <a:r>
               <a:rPr lang="en-US" dirty="0">
                 <a:solidFill>
@@ -3391,8 +3395,8 @@
         </p:nvSpPr>
         <p:spPr>
           <a:xfrm>
-            <a:off x="1993392" y="3146536"/>
-            <a:ext cx="5084064" cy="1004840"/>
+            <a:off x="1993392" y="4048236"/>
+            <a:ext cx="4407408" cy="1004840"/>
           </a:xfrm>
           <a:prstGeom prst="rect">
             <a:avLst/>
@@ -3451,7 +3455,7 @@
         </p:nvSpPr>
         <p:spPr>
           <a:xfrm>
-            <a:off x="1993392" y="2542032"/>
+            <a:off x="1993392" y="3443732"/>
             <a:ext cx="1828800" cy="420624"/>
           </a:xfrm>
           <a:prstGeom prst="rect">
@@ -3500,7 +3504,7 @@
         </p:nvSpPr>
         <p:spPr>
           <a:xfrm>
-            <a:off x="5903974" y="2450592"/>
+            <a:off x="5236462" y="3352292"/>
             <a:ext cx="1173482" cy="548640"/>
           </a:xfrm>
           <a:prstGeom prst="rect">
@@ -3549,7 +3553,7 @@
         </p:nvSpPr>
         <p:spPr>
           <a:xfrm>
-            <a:off x="5903974" y="1837944"/>
+            <a:off x="5236462" y="2739644"/>
             <a:ext cx="1173482" cy="548640"/>
           </a:xfrm>
           <a:prstGeom prst="rect">
@@ -3598,7 +3602,7 @@
         </p:nvSpPr>
         <p:spPr>
           <a:xfrm>
-            <a:off x="7420353" y="3026664"/>
+            <a:off x="6478905" y="4056380"/>
             <a:ext cx="1173482" cy="548640"/>
           </a:xfrm>
           <a:prstGeom prst="rect">
@@ -3647,7 +3651,7 @@
         </p:nvSpPr>
         <p:spPr>
           <a:xfrm>
-            <a:off x="7453117" y="3621024"/>
+            <a:off x="6484237" y="4650740"/>
             <a:ext cx="1173482" cy="548640"/>
           </a:xfrm>
           <a:prstGeom prst="rect">
@@ -3692,14 +3696,14 @@
             </a:extLst>
           </p:cNvPr>
           <p:cNvCxnSpPr>
-            <a:endCxn id="4" idx="3"/>
+            <a:cxnSpLocks/>
           </p:cNvCxnSpPr>
           <p:nvPr/>
         </p:nvCxnSpPr>
         <p:spPr>
-          <a:xfrm flipH="1" flipV="1">
-            <a:off x="9098280" y="3058668"/>
-            <a:ext cx="2459736" cy="0"/>
+          <a:xfrm flipH="1">
+            <a:off x="10634472" y="4586732"/>
+            <a:ext cx="808228" cy="0"/>
           </a:xfrm>
           <a:prstGeom prst="straightConnector1">
             <a:avLst/>
@@ -3737,7 +3741,7 @@
         </p:nvSpPr>
         <p:spPr>
           <a:xfrm>
-            <a:off x="9683496" y="2542032"/>
+            <a:off x="10634472" y="3745960"/>
             <a:ext cx="2011680" cy="369332"/>
           </a:xfrm>
           <a:prstGeom prst="rect">
@@ -3773,9 +3777,9 @@
           <p:nvPr/>
         </p:nvCxnSpPr>
         <p:spPr>
-          <a:xfrm flipH="1" flipV="1">
-            <a:off x="6446520" y="794004"/>
-            <a:ext cx="0" cy="914400"/>
+          <a:xfrm flipV="1">
+            <a:off x="5823203" y="803902"/>
+            <a:ext cx="0" cy="777240"/>
           </a:xfrm>
           <a:prstGeom prst="straightConnector1">
             <a:avLst/>
@@ -3813,7 +3817,7 @@
         </p:nvSpPr>
         <p:spPr>
           <a:xfrm>
-            <a:off x="6490715" y="763524"/>
+            <a:off x="5823203" y="941562"/>
             <a:ext cx="2011680" cy="369332"/>
           </a:xfrm>
           <a:prstGeom prst="rect">
@@ -3848,7 +3852,7 @@
         </p:nvSpPr>
         <p:spPr>
           <a:xfrm>
-            <a:off x="5522208" y="3429000"/>
+            <a:off x="5082539" y="5290820"/>
             <a:ext cx="1408176" cy="676656"/>
           </a:xfrm>
           <a:prstGeom prst="rect">
@@ -3878,7 +3882,154 @@
             <a:pPr algn="ctr"/>
             <a:r>
               <a:rPr lang="en-US" dirty="0"/>
-              <a:t>HP SEAL SET</a:t>
+              <a:t>HP SEAL GROUP</a:t>
+            </a:r>
+          </a:p>
+        </p:txBody>
+      </p:sp>
+      <p:sp>
+        <p:nvSpPr>
+          <p:cNvPr id="19" name="Rectangle 18">
+            <a:extLst>
+              <a:ext uri="{FF2B5EF4-FFF2-40B4-BE49-F238E27FC236}">
+                <a16:creationId xmlns:a16="http://schemas.microsoft.com/office/drawing/2014/main" id="{6F392304-BC17-A01A-CB84-5BB6FB7954CE}"/>
+              </a:ext>
+            </a:extLst>
+          </p:cNvPr>
+          <p:cNvSpPr/>
+          <p:nvPr/>
+        </p:nvSpPr>
+        <p:spPr>
+          <a:xfrm>
+            <a:off x="7757543" y="4248404"/>
+            <a:ext cx="1285873" cy="676656"/>
+          </a:xfrm>
+          <a:prstGeom prst="rect">
+            <a:avLst/>
+          </a:prstGeom>
+        </p:spPr>
+        <p:style>
+          <a:lnRef idx="2">
+            <a:schemeClr val="accent1">
+              <a:shade val="15000"/>
+            </a:schemeClr>
+          </a:lnRef>
+          <a:fillRef idx="1">
+            <a:schemeClr val="accent1"/>
+          </a:fillRef>
+          <a:effectRef idx="0">
+            <a:schemeClr val="accent1"/>
+          </a:effectRef>
+          <a:fontRef idx="minor">
+            <a:schemeClr val="lt1"/>
+          </a:fontRef>
+        </p:style>
+        <p:txBody>
+          <a:bodyPr rtlCol="0" anchor="ctr"/>
+          <a:lstStyle/>
+          <a:p>
+            <a:pPr algn="ctr"/>
+            <a:r>
+              <a:rPr lang="en-US" dirty="0"/>
+              <a:t>HEAD BLOCK</a:t>
+            </a:r>
+          </a:p>
+        </p:txBody>
+      </p:sp>
+      <p:sp>
+        <p:nvSpPr>
+          <p:cNvPr id="23" name="Rectangle 22">
+            <a:extLst>
+              <a:ext uri="{FF2B5EF4-FFF2-40B4-BE49-F238E27FC236}">
+                <a16:creationId xmlns:a16="http://schemas.microsoft.com/office/drawing/2014/main" id="{F87C9388-4B82-D245-0E07-18E2284F528B}"/>
+              </a:ext>
+            </a:extLst>
+          </p:cNvPr>
+          <p:cNvSpPr/>
+          <p:nvPr/>
+        </p:nvSpPr>
+        <p:spPr>
+          <a:xfrm>
+            <a:off x="9143240" y="4248404"/>
+            <a:ext cx="1372360" cy="676656"/>
+          </a:xfrm>
+          <a:prstGeom prst="rect">
+            <a:avLst/>
+          </a:prstGeom>
+        </p:spPr>
+        <p:style>
+          <a:lnRef idx="2">
+            <a:schemeClr val="accent1">
+              <a:shade val="15000"/>
+            </a:schemeClr>
+          </a:lnRef>
+          <a:fillRef idx="1">
+            <a:schemeClr val="accent1"/>
+          </a:fillRef>
+          <a:effectRef idx="0">
+            <a:schemeClr val="accent1"/>
+          </a:effectRef>
+          <a:fontRef idx="minor">
+            <a:schemeClr val="lt1"/>
+          </a:fontRef>
+        </p:style>
+        <p:txBody>
+          <a:bodyPr rtlCol="0" anchor="ctr"/>
+          <a:lstStyle/>
+          <a:p>
+            <a:pPr algn="ctr"/>
+            <a:r>
+              <a:rPr lang="en-US" dirty="0"/>
+              <a:t>RETAINING RING</a:t>
+            </a:r>
+          </a:p>
+        </p:txBody>
+      </p:sp>
+      <p:sp>
+        <p:nvSpPr>
+          <p:cNvPr id="26" name="Rectangle 25">
+            <a:extLst>
+              <a:ext uri="{FF2B5EF4-FFF2-40B4-BE49-F238E27FC236}">
+                <a16:creationId xmlns:a16="http://schemas.microsoft.com/office/drawing/2014/main" id="{2565252D-0F0E-75D0-3C82-DE1694E1394D}"/>
+              </a:ext>
+            </a:extLst>
+          </p:cNvPr>
+          <p:cNvSpPr/>
+          <p:nvPr/>
+        </p:nvSpPr>
+        <p:spPr>
+          <a:xfrm>
+            <a:off x="5236462" y="1587500"/>
+            <a:ext cx="1173482" cy="548640"/>
+          </a:xfrm>
+          <a:prstGeom prst="rect">
+            <a:avLst/>
+          </a:prstGeom>
+        </p:spPr>
+        <p:style>
+          <a:lnRef idx="2">
+            <a:schemeClr val="accent1">
+              <a:shade val="15000"/>
+            </a:schemeClr>
+          </a:lnRef>
+          <a:fillRef idx="1">
+            <a:schemeClr val="accent1"/>
+          </a:fillRef>
+          <a:effectRef idx="0">
+            <a:schemeClr val="accent1"/>
+          </a:effectRef>
+          <a:fontRef idx="minor">
+            <a:schemeClr val="lt1"/>
+          </a:fontRef>
+        </p:style>
+        <p:txBody>
+          <a:bodyPr rtlCol="0" anchor="ctr"/>
+          <a:lstStyle/>
+          <a:p>
+            <a:pPr algn="ctr"/>
+            <a:r>
+              <a:rPr lang="en-US" dirty="0"/>
+              <a:t>IN-LINE DCV</a:t>
             </a:r>
           </a:p>
         </p:txBody>

</xml_diff>